<commit_message>
Proficiency Opportunity: shorter big numbers and tile label so they fit
Co-Authored-By: Claude Opus 5.5 <noreply@anthropic.com>
Claude-Session: https://claude.ai/code/session_01Xa4nFVxuQGXmHARGph9WhS
</commit_message>
<xml_diff>
--- a/day2-deck/decks/Technician Proficiency - House Style.pptx
+++ b/day2-deck/decks/Technician Proficiency - House Style.pptx
@@ -15197,7 +15197,7 @@
                 <a:ea typeface="Inter" pitchFamily="34" charset="-122"/>
                 <a:cs typeface="Inter" pitchFamily="34" charset="-120"/>
               </a:rPr>
-              <a:t>HOURS NOT PRODUCED, YEAR TO DATE</a:t>
+              <a:t>HOURS NOT PRODUCED YTD</a:t>
             </a:r>
             <a:endParaRPr lang="en-US" sz="1400" dirty="0"/>
           </a:p>
@@ -15238,7 +15238,7 @@
                 <a:ea typeface="Inter" pitchFamily="34" charset="-122"/>
                 <a:cs typeface="Inter" pitchFamily="34" charset="-120"/>
               </a:rPr>
-              <a:t>79K YTD</a:t>
+              <a:t>79K</a:t>
             </a:r>
             <a:endParaRPr lang="en-US" sz="4000" dirty="0"/>
           </a:p>
@@ -15397,7 +15397,7 @@
                 <a:ea typeface="Inter" pitchFamily="34" charset="-122"/>
                 <a:cs typeface="Inter" pitchFamily="34" charset="-120"/>
               </a:rPr>
-              <a:t>262 of 583</a:t>
+              <a:t>262</a:t>
             </a:r>
             <a:endParaRPr lang="en-US" sz="4000" dirty="0"/>
           </a:p>
@@ -15436,7 +15436,7 @@
                 <a:ea typeface="Inter" pitchFamily="34" charset="-122"/>
                 <a:cs typeface="Inter" pitchFamily="34" charset="-120"/>
               </a:rPr>
-              <a:t>45% of technicians. Every store has at least one.</a:t>
+              <a:t>Of 583 technicians (45%). Every store has at least one.</a:t>
             </a:r>
             <a:endParaRPr lang="en-US" sz="1500" dirty="0"/>
           </a:p>

</xml_diff>